<commit_message>
backend package refactor and community feature
</commit_message>
<xml_diff>
--- a/DB산출물/05_ERD.pptx
+++ b/DB산출물/05_ERD.pptx
@@ -260,7 +260,7 @@
           <a:p>
             <a:fld id="{C6EE36B7-F0BA-4AB3-BD67-20AC5E002CC9}" type="datetimeFigureOut">
               <a:rPr lang="ko-KR" altLang="en-US" smtClean="0"/>
-              <a:t>2026-05-14</a:t>
+              <a:t>2026-05-15</a:t>
             </a:fld>
             <a:endParaRPr lang="ko-KR" altLang="en-US"/>
           </a:p>
@@ -458,7 +458,7 @@
           <a:p>
             <a:fld id="{C6EE36B7-F0BA-4AB3-BD67-20AC5E002CC9}" type="datetimeFigureOut">
               <a:rPr lang="ko-KR" altLang="en-US" smtClean="0"/>
-              <a:t>2026-05-14</a:t>
+              <a:t>2026-05-15</a:t>
             </a:fld>
             <a:endParaRPr lang="ko-KR" altLang="en-US"/>
           </a:p>
@@ -666,7 +666,7 @@
           <a:p>
             <a:fld id="{C6EE36B7-F0BA-4AB3-BD67-20AC5E002CC9}" type="datetimeFigureOut">
               <a:rPr lang="ko-KR" altLang="en-US" smtClean="0"/>
-              <a:t>2026-05-14</a:t>
+              <a:t>2026-05-15</a:t>
             </a:fld>
             <a:endParaRPr lang="ko-KR" altLang="en-US"/>
           </a:p>
@@ -864,7 +864,7 @@
           <a:p>
             <a:fld id="{C6EE36B7-F0BA-4AB3-BD67-20AC5E002CC9}" type="datetimeFigureOut">
               <a:rPr lang="ko-KR" altLang="en-US" smtClean="0"/>
-              <a:t>2026-05-14</a:t>
+              <a:t>2026-05-15</a:t>
             </a:fld>
             <a:endParaRPr lang="ko-KR" altLang="en-US"/>
           </a:p>
@@ -1139,7 +1139,7 @@
           <a:p>
             <a:fld id="{C6EE36B7-F0BA-4AB3-BD67-20AC5E002CC9}" type="datetimeFigureOut">
               <a:rPr lang="ko-KR" altLang="en-US" smtClean="0"/>
-              <a:t>2026-05-14</a:t>
+              <a:t>2026-05-15</a:t>
             </a:fld>
             <a:endParaRPr lang="ko-KR" altLang="en-US"/>
           </a:p>
@@ -1404,7 +1404,7 @@
           <a:p>
             <a:fld id="{C6EE36B7-F0BA-4AB3-BD67-20AC5E002CC9}" type="datetimeFigureOut">
               <a:rPr lang="ko-KR" altLang="en-US" smtClean="0"/>
-              <a:t>2026-05-14</a:t>
+              <a:t>2026-05-15</a:t>
             </a:fld>
             <a:endParaRPr lang="ko-KR" altLang="en-US"/>
           </a:p>
@@ -1816,7 +1816,7 @@
           <a:p>
             <a:fld id="{C6EE36B7-F0BA-4AB3-BD67-20AC5E002CC9}" type="datetimeFigureOut">
               <a:rPr lang="ko-KR" altLang="en-US" smtClean="0"/>
-              <a:t>2026-05-14</a:t>
+              <a:t>2026-05-15</a:t>
             </a:fld>
             <a:endParaRPr lang="ko-KR" altLang="en-US"/>
           </a:p>
@@ -1957,7 +1957,7 @@
           <a:p>
             <a:fld id="{C6EE36B7-F0BA-4AB3-BD67-20AC5E002CC9}" type="datetimeFigureOut">
               <a:rPr lang="ko-KR" altLang="en-US" smtClean="0"/>
-              <a:t>2026-05-14</a:t>
+              <a:t>2026-05-15</a:t>
             </a:fld>
             <a:endParaRPr lang="ko-KR" altLang="en-US"/>
           </a:p>
@@ -2070,7 +2070,7 @@
           <a:p>
             <a:fld id="{C6EE36B7-F0BA-4AB3-BD67-20AC5E002CC9}" type="datetimeFigureOut">
               <a:rPr lang="ko-KR" altLang="en-US" smtClean="0"/>
-              <a:t>2026-05-14</a:t>
+              <a:t>2026-05-15</a:t>
             </a:fld>
             <a:endParaRPr lang="ko-KR" altLang="en-US"/>
           </a:p>
@@ -2381,7 +2381,7 @@
           <a:p>
             <a:fld id="{C6EE36B7-F0BA-4AB3-BD67-20AC5E002CC9}" type="datetimeFigureOut">
               <a:rPr lang="ko-KR" altLang="en-US" smtClean="0"/>
-              <a:t>2026-05-14</a:t>
+              <a:t>2026-05-15</a:t>
             </a:fld>
             <a:endParaRPr lang="ko-KR" altLang="en-US"/>
           </a:p>
@@ -2669,7 +2669,7 @@
           <a:p>
             <a:fld id="{C6EE36B7-F0BA-4AB3-BD67-20AC5E002CC9}" type="datetimeFigureOut">
               <a:rPr lang="ko-KR" altLang="en-US" smtClean="0"/>
-              <a:t>2026-05-14</a:t>
+              <a:t>2026-05-15</a:t>
             </a:fld>
             <a:endParaRPr lang="ko-KR" altLang="en-US"/>
           </a:p>
@@ -2910,7 +2910,7 @@
           <a:p>
             <a:fld id="{C6EE36B7-F0BA-4AB3-BD67-20AC5E002CC9}" type="datetimeFigureOut">
               <a:rPr lang="ko-KR" altLang="en-US" smtClean="0"/>
-              <a:t>2026-05-14</a:t>
+              <a:t>2026-05-15</a:t>
             </a:fld>
             <a:endParaRPr lang="ko-KR" altLang="en-US"/>
           </a:p>
@@ -3436,14 +3436,14 @@
           <p:nvPr>
             <p:extLst>
               <p:ext uri="{D42A27DB-BD31-4B8C-83A1-F6EECF244321}">
-                <p14:modId xmlns:p14="http://schemas.microsoft.com/office/powerpoint/2010/main" val="2110844107"/>
+                <p14:modId xmlns:p14="http://schemas.microsoft.com/office/powerpoint/2010/main" val="1934124536"/>
               </p:ext>
             </p:extLst>
           </p:nvPr>
         </p:nvGraphicFramePr>
         <p:xfrm>
           <a:off x="491065" y="880533"/>
-          <a:ext cx="4419602" cy="2556936"/>
+          <a:ext cx="4419602" cy="2277480"/>
         </p:xfrm>
         <a:graphic>
           <a:graphicData uri="http://schemas.openxmlformats.org/drawingml/2006/table">
@@ -4087,117 +4087,6 @@
                   </a:ext>
                 </a:extLst>
               </a:tr>
-              <a:tr h="279456">
-                <a:tc>
-                  <a:txBody>
-                    <a:bodyPr/>
-                    <a:lstStyle/>
-                    <a:p>
-                      <a:pPr marL="0" marR="0" lvl="0" indent="0" algn="ctr" defTabSz="914400" rtl="0" eaLnBrk="1" fontAlgn="auto" latinLnBrk="1" hangingPunct="1">
-                        <a:lnSpc>
-                          <a:spcPct val="100000"/>
-                        </a:lnSpc>
-                        <a:spcBef>
-                          <a:spcPts val="0"/>
-                        </a:spcBef>
-                        <a:spcAft>
-                          <a:spcPts val="0"/>
-                        </a:spcAft>
-                        <a:buClrTx/>
-                        <a:buSzTx/>
-                        <a:buFontTx/>
-                        <a:buNone/>
-                        <a:tabLst/>
-                        <a:defRPr/>
-                      </a:pPr>
-                      <a:r>
-                        <a:rPr lang="en-US" altLang="ko-KR" sz="1200" dirty="0">
-                          <a:latin typeface="+mj-lt"/>
-                        </a:rPr>
-                        <a:t>MEM_EDU</a:t>
-                      </a:r>
-                    </a:p>
-                  </a:txBody>
-                  <a:tcPr anchor="ctr"/>
-                </a:tc>
-                <a:tc>
-                  <a:txBody>
-                    <a:bodyPr/>
-                    <a:lstStyle/>
-                    <a:p>
-                      <a:pPr marL="0" marR="0" lvl="0" indent="0" algn="ctr" defTabSz="914400" rtl="0" eaLnBrk="1" fontAlgn="auto" latinLnBrk="1" hangingPunct="1">
-                        <a:lnSpc>
-                          <a:spcPct val="100000"/>
-                        </a:lnSpc>
-                        <a:spcBef>
-                          <a:spcPts val="0"/>
-                        </a:spcBef>
-                        <a:spcAft>
-                          <a:spcPts val="0"/>
-                        </a:spcAft>
-                        <a:buClrTx/>
-                        <a:buSzTx/>
-                        <a:buFontTx/>
-                        <a:buNone/>
-                        <a:tabLst/>
-                        <a:defRPr/>
-                      </a:pPr>
-                      <a:r>
-                        <a:rPr lang="en-US" altLang="ko-KR" sz="1200" kern="1200" dirty="0">
-                          <a:solidFill>
-                            <a:schemeClr val="dk1"/>
-                          </a:solidFill>
-                          <a:latin typeface="+mn-lt"/>
-                          <a:ea typeface="+mn-ea"/>
-                          <a:cs typeface="+mn-cs"/>
-                        </a:rPr>
-                        <a:t>varchar(5)</a:t>
-                      </a:r>
-                    </a:p>
-                  </a:txBody>
-                  <a:tcPr anchor="ctr"/>
-                </a:tc>
-                <a:tc>
-                  <a:txBody>
-                    <a:bodyPr/>
-                    <a:lstStyle/>
-                    <a:p>
-                      <a:pPr marL="0" marR="0" lvl="0" indent="0" algn="ctr" defTabSz="914400" rtl="0" eaLnBrk="1" fontAlgn="auto" latinLnBrk="1" hangingPunct="1">
-                        <a:lnSpc>
-                          <a:spcPct val="100000"/>
-                        </a:lnSpc>
-                        <a:spcBef>
-                          <a:spcPts val="0"/>
-                        </a:spcBef>
-                        <a:spcAft>
-                          <a:spcPts val="0"/>
-                        </a:spcAft>
-                        <a:buClrTx/>
-                        <a:buSzTx/>
-                        <a:buFontTx/>
-                        <a:buNone/>
-                        <a:tabLst/>
-                        <a:defRPr/>
-                      </a:pPr>
-                      <a:r>
-                        <a:rPr lang="ko-KR" altLang="en-US" sz="1200" dirty="0">
-                          <a:latin typeface="+mj-lt"/>
-                        </a:rPr>
-                        <a:t>교육수준</a:t>
-                      </a:r>
-                      <a:endParaRPr lang="en-US" altLang="ko-KR" sz="1200" dirty="0">
-                        <a:latin typeface="+mj-lt"/>
-                      </a:endParaRPr>
-                    </a:p>
-                  </a:txBody>
-                  <a:tcPr anchor="ctr"/>
-                </a:tc>
-                <a:extLst>
-                  <a:ext uri="{0D108BD9-81ED-4DB2-BD59-A6C34878D82A}">
-                    <a16:rowId xmlns:a16="http://schemas.microsoft.com/office/drawing/2014/main" val="1409380143"/>
-                  </a:ext>
-                </a:extLst>
-              </a:tr>
               <a:tr h="276866">
                 <a:tc>
                   <a:txBody>
@@ -4328,14 +4217,14 @@
           <p:nvPr>
             <p:extLst>
               <p:ext uri="{D42A27DB-BD31-4B8C-83A1-F6EECF244321}">
-                <p14:modId xmlns:p14="http://schemas.microsoft.com/office/powerpoint/2010/main" val="3116708836"/>
+                <p14:modId xmlns:p14="http://schemas.microsoft.com/office/powerpoint/2010/main" val="3191278033"/>
               </p:ext>
             </p:extLst>
           </p:nvPr>
         </p:nvGraphicFramePr>
         <p:xfrm>
-          <a:off x="7006183" y="488866"/>
-          <a:ext cx="4730748" cy="6096000"/>
+          <a:off x="6993468" y="277200"/>
+          <a:ext cx="4730748" cy="6339840"/>
         </p:xfrm>
         <a:graphic>
           <a:graphicData uri="http://schemas.openxmlformats.org/drawingml/2006/table">
@@ -4377,19 +4266,7 @@
                         <a:rPr lang="en-US" altLang="ko-KR" sz="1000" dirty="0">
                           <a:latin typeface="+mj-lt"/>
                         </a:rPr>
-                        <a:t>HEALTH</a:t>
-                      </a:r>
-                      <a:r>
-                        <a:rPr lang="ko-KR" altLang="en-US" sz="1000" dirty="0">
-                          <a:latin typeface="+mj-lt"/>
-                        </a:rPr>
-                        <a:t> </a:t>
-                      </a:r>
-                      <a:r>
-                        <a:rPr lang="en-US" altLang="ko-KR" sz="1000" dirty="0">
-                          <a:latin typeface="+mj-lt"/>
-                        </a:rPr>
-                        <a:t>DIAGNOSE</a:t>
+                        <a:t>DATA</a:t>
                       </a:r>
                       <a:endParaRPr lang="ko-KR" altLang="en-US" sz="1000" dirty="0">
                         <a:latin typeface="+mj-lt"/>
@@ -4499,7 +4376,7 @@
                         <a:rPr lang="en-US" altLang="ko-KR" sz="1000" dirty="0">
                           <a:latin typeface="+mj-lt"/>
                         </a:rPr>
-                        <a:t>DIAGNOSIS_ID(PK)</a:t>
+                        <a:t>DATA_ID(PK)</a:t>
                       </a:r>
                       <a:endParaRPr lang="ko-KR" altLang="en-US" sz="1000" dirty="0">
                         <a:latin typeface="+mj-lt"/>
@@ -6498,7 +6375,29 @@
                           <a:ea typeface="+mn-ea"/>
                           <a:cs typeface="+mn-cs"/>
                         </a:rPr>
-                        <a:t>NUMBER(3, 1)</a:t>
+                        <a:t>NUMBER</a:t>
+                      </a:r>
+                      <a:r>
+                        <a:rPr lang="en-US" altLang="ko-KR" sz="1000" kern="1200">
+                          <a:solidFill>
+                            <a:schemeClr val="dk1"/>
+                          </a:solidFill>
+                          <a:latin typeface="+mj-lt"/>
+                          <a:ea typeface="+mn-ea"/>
+                          <a:cs typeface="+mn-cs"/>
+                        </a:rPr>
+                        <a:t>(3,1</a:t>
+                      </a:r>
+                      <a:r>
+                        <a:rPr lang="en-US" altLang="ko-KR" sz="1000" kern="1200" dirty="0">
+                          <a:solidFill>
+                            <a:schemeClr val="dk1"/>
+                          </a:solidFill>
+                          <a:latin typeface="+mj-lt"/>
+                          <a:ea typeface="+mn-ea"/>
+                          <a:cs typeface="+mn-cs"/>
+                        </a:rPr>
+                        <a:t>)</a:t>
                       </a:r>
                       <a:endParaRPr lang="ko-KR" altLang="en-US" sz="1000" kern="1200" dirty="0">
                         <a:solidFill>
@@ -6547,6 +6446,109 @@
                 <a:extLst>
                   <a:ext uri="{0D108BD9-81ED-4DB2-BD59-A6C34878D82A}">
                     <a16:rowId xmlns:a16="http://schemas.microsoft.com/office/drawing/2014/main" val="3503901649"/>
+                  </a:ext>
+                </a:extLst>
+              </a:tr>
+              <a:tr h="174682">
+                <a:tc>
+                  <a:txBody>
+                    <a:bodyPr/>
+                    <a:lstStyle/>
+                    <a:p>
+                      <a:pPr algn="ctr" latinLnBrk="1"/>
+                      <a:r>
+                        <a:rPr lang="en-US" altLang="ko-KR" sz="1000" dirty="0">
+                          <a:latin typeface="+mj-lt"/>
+                        </a:rPr>
+                        <a:t>predict</a:t>
+                      </a:r>
+                      <a:endParaRPr lang="ko-KR" altLang="en-US" sz="1000" dirty="0">
+                        <a:latin typeface="+mj-lt"/>
+                      </a:endParaRPr>
+                    </a:p>
+                  </a:txBody>
+                  <a:tcPr anchor="ctr"/>
+                </a:tc>
+                <a:tc>
+                  <a:txBody>
+                    <a:bodyPr/>
+                    <a:lstStyle/>
+                    <a:p>
+                      <a:pPr marL="0" marR="0" lvl="0" indent="0" algn="ctr" defTabSz="914400" rtl="0" eaLnBrk="1" fontAlgn="auto" latinLnBrk="1" hangingPunct="1">
+                        <a:lnSpc>
+                          <a:spcPct val="100000"/>
+                        </a:lnSpc>
+                        <a:spcBef>
+                          <a:spcPts val="0"/>
+                        </a:spcBef>
+                        <a:spcAft>
+                          <a:spcPts val="0"/>
+                        </a:spcAft>
+                        <a:buClrTx/>
+                        <a:buSzTx/>
+                        <a:buFontTx/>
+                        <a:buNone/>
+                        <a:tabLst/>
+                        <a:defRPr/>
+                      </a:pPr>
+                      <a:r>
+                        <a:rPr lang="en-US" altLang="ko-KR" sz="1000" kern="1200" dirty="0">
+                          <a:solidFill>
+                            <a:schemeClr val="dk1"/>
+                          </a:solidFill>
+                          <a:latin typeface="+mj-lt"/>
+                          <a:ea typeface="+mn-ea"/>
+                          <a:cs typeface="+mn-cs"/>
+                        </a:rPr>
+                        <a:t>NUMBER(5,4)</a:t>
+                      </a:r>
+                      <a:endParaRPr lang="ko-KR" altLang="en-US" sz="1000" kern="1200" dirty="0">
+                        <a:solidFill>
+                          <a:schemeClr val="dk1"/>
+                        </a:solidFill>
+                        <a:latin typeface="+mj-lt"/>
+                        <a:ea typeface="+mn-ea"/>
+                        <a:cs typeface="+mn-cs"/>
+                      </a:endParaRPr>
+                    </a:p>
+                  </a:txBody>
+                  <a:tcPr anchor="ctr"/>
+                </a:tc>
+                <a:tc>
+                  <a:txBody>
+                    <a:bodyPr/>
+                    <a:lstStyle/>
+                    <a:p>
+                      <a:pPr marL="0" marR="0" lvl="0" indent="0" algn="ctr" defTabSz="914400" rtl="0" eaLnBrk="1" fontAlgn="auto" latinLnBrk="1" hangingPunct="1">
+                        <a:lnSpc>
+                          <a:spcPct val="100000"/>
+                        </a:lnSpc>
+                        <a:spcBef>
+                          <a:spcPts val="0"/>
+                        </a:spcBef>
+                        <a:spcAft>
+                          <a:spcPts val="0"/>
+                        </a:spcAft>
+                        <a:buClrTx/>
+                        <a:buSzTx/>
+                        <a:buFontTx/>
+                        <a:buNone/>
+                        <a:tabLst/>
+                        <a:defRPr/>
+                      </a:pPr>
+                      <a:r>
+                        <a:rPr lang="ko-KR" altLang="en-US" sz="1000" dirty="0">
+                          <a:latin typeface="+mj-lt"/>
+                        </a:rPr>
+                        <a:t>예측결과</a:t>
+                      </a:r>
+                    </a:p>
+                  </a:txBody>
+                  <a:tcPr anchor="ctr"/>
+                </a:tc>
+                <a:extLst>
+                  <a:ext uri="{0D108BD9-81ED-4DB2-BD59-A6C34878D82A}">
+                    <a16:rowId xmlns:a16="http://schemas.microsoft.com/office/drawing/2014/main" val="559573949"/>
                   </a:ext>
                 </a:extLst>
               </a:tr>
@@ -7115,13 +7117,14 @@
           </p:cNvPr>
           <p:cNvCxnSpPr>
             <a:cxnSpLocks/>
+            <a:stCxn id="59" idx="2"/>
           </p:cNvCxnSpPr>
           <p:nvPr/>
         </p:nvCxnSpPr>
         <p:spPr>
           <a:xfrm>
-            <a:off x="2700876" y="3429000"/>
-            <a:ext cx="0" cy="709504"/>
+            <a:off x="2700866" y="3158013"/>
+            <a:ext cx="10" cy="980491"/>
           </a:xfrm>
           <a:prstGeom prst="line">
             <a:avLst/>
@@ -7457,153 +7460,6 @@
       </p:sp>
       <p:sp>
         <p:nvSpPr>
-          <p:cNvPr id="54" name="타원 53">
-            <a:extLst>
-              <a:ext uri="{FF2B5EF4-FFF2-40B4-BE49-F238E27FC236}">
-                <a16:creationId xmlns:a16="http://schemas.microsoft.com/office/drawing/2014/main" id="{B9525ECA-2050-4F48-9C79-3F27E8811109}"/>
-              </a:ext>
-            </a:extLst>
-          </p:cNvPr>
-          <p:cNvSpPr/>
-          <p:nvPr/>
-        </p:nvSpPr>
-        <p:spPr>
-          <a:xfrm>
-            <a:off x="6832612" y="3887563"/>
-            <a:ext cx="78314" cy="93364"/>
-          </a:xfrm>
-          <a:prstGeom prst="ellipse">
-            <a:avLst/>
-          </a:prstGeom>
-          <a:solidFill>
-            <a:schemeClr val="bg1"/>
-          </a:solidFill>
-        </p:spPr>
-        <p:style>
-          <a:lnRef idx="2">
-            <a:schemeClr val="accent1">
-              <a:shade val="50000"/>
-            </a:schemeClr>
-          </a:lnRef>
-          <a:fillRef idx="1">
-            <a:schemeClr val="accent1"/>
-          </a:fillRef>
-          <a:effectRef idx="0">
-            <a:schemeClr val="accent1"/>
-          </a:effectRef>
-          <a:fontRef idx="minor">
-            <a:schemeClr val="lt1"/>
-          </a:fontRef>
-        </p:style>
-        <p:txBody>
-          <a:bodyPr rtlCol="0" anchor="ctr"/>
-          <a:lstStyle/>
-          <a:p>
-            <a:pPr algn="ctr"/>
-            <a:endParaRPr lang="ko-KR" altLang="en-US"/>
-          </a:p>
-        </p:txBody>
-      </p:sp>
-      <p:sp>
-        <p:nvSpPr>
-          <p:cNvPr id="55" name="타원 54">
-            <a:extLst>
-              <a:ext uri="{FF2B5EF4-FFF2-40B4-BE49-F238E27FC236}">
-                <a16:creationId xmlns:a16="http://schemas.microsoft.com/office/drawing/2014/main" id="{51BB29CA-C66D-4A2A-B48C-26B33C252201}"/>
-              </a:ext>
-            </a:extLst>
-          </p:cNvPr>
-          <p:cNvSpPr/>
-          <p:nvPr/>
-        </p:nvSpPr>
-        <p:spPr>
-          <a:xfrm>
-            <a:off x="2667004" y="3438827"/>
-            <a:ext cx="78314" cy="93364"/>
-          </a:xfrm>
-          <a:prstGeom prst="ellipse">
-            <a:avLst/>
-          </a:prstGeom>
-          <a:solidFill>
-            <a:schemeClr val="bg1"/>
-          </a:solidFill>
-        </p:spPr>
-        <p:style>
-          <a:lnRef idx="2">
-            <a:schemeClr val="accent1">
-              <a:shade val="50000"/>
-            </a:schemeClr>
-          </a:lnRef>
-          <a:fillRef idx="1">
-            <a:schemeClr val="accent1"/>
-          </a:fillRef>
-          <a:effectRef idx="0">
-            <a:schemeClr val="accent1"/>
-          </a:effectRef>
-          <a:fontRef idx="minor">
-            <a:schemeClr val="lt1"/>
-          </a:fontRef>
-        </p:style>
-        <p:txBody>
-          <a:bodyPr rtlCol="0" anchor="ctr"/>
-          <a:lstStyle/>
-          <a:p>
-            <a:pPr algn="ctr"/>
-            <a:endParaRPr lang="ko-KR" altLang="en-US"/>
-          </a:p>
-        </p:txBody>
-      </p:sp>
-      <p:sp>
-        <p:nvSpPr>
-          <p:cNvPr id="56" name="타원 55">
-            <a:extLst>
-              <a:ext uri="{FF2B5EF4-FFF2-40B4-BE49-F238E27FC236}">
-                <a16:creationId xmlns:a16="http://schemas.microsoft.com/office/drawing/2014/main" id="{7B22E300-D6A0-467C-A2C5-B407873F39B0}"/>
-              </a:ext>
-            </a:extLst>
-          </p:cNvPr>
-          <p:cNvSpPr/>
-          <p:nvPr/>
-        </p:nvSpPr>
-        <p:spPr>
-          <a:xfrm>
-            <a:off x="2658540" y="4065361"/>
-            <a:ext cx="78314" cy="93364"/>
-          </a:xfrm>
-          <a:prstGeom prst="ellipse">
-            <a:avLst/>
-          </a:prstGeom>
-          <a:solidFill>
-            <a:schemeClr val="bg1"/>
-          </a:solidFill>
-        </p:spPr>
-        <p:style>
-          <a:lnRef idx="2">
-            <a:schemeClr val="accent1">
-              <a:shade val="50000"/>
-            </a:schemeClr>
-          </a:lnRef>
-          <a:fillRef idx="1">
-            <a:schemeClr val="accent1"/>
-          </a:fillRef>
-          <a:effectRef idx="0">
-            <a:schemeClr val="accent1"/>
-          </a:effectRef>
-          <a:fontRef idx="minor">
-            <a:schemeClr val="lt1"/>
-          </a:fontRef>
-        </p:style>
-        <p:txBody>
-          <a:bodyPr rtlCol="0" anchor="ctr"/>
-          <a:lstStyle/>
-          <a:p>
-            <a:pPr algn="ctr"/>
-            <a:endParaRPr lang="ko-KR" altLang="en-US"/>
-          </a:p>
-        </p:txBody>
-      </p:sp>
-      <p:sp>
-        <p:nvSpPr>
           <p:cNvPr id="57" name="TextBox 56">
             <a:extLst>
               <a:ext uri="{FF2B5EF4-FFF2-40B4-BE49-F238E27FC236}">
@@ -7616,7 +7472,7 @@
         </p:nvSpPr>
         <p:spPr>
           <a:xfrm flipH="1">
-            <a:off x="2688171" y="3384479"/>
+            <a:off x="2654299" y="3082849"/>
             <a:ext cx="194730" cy="215444"/>
           </a:xfrm>
           <a:prstGeom prst="rect">

</xml_diff>